<commit_message>
BasicVectorConcepts added to unit01
</commit_message>
<xml_diff>
--- a/chapter_notes/pptx/Unit-02 Pointers.pptx
+++ b/chapter_notes/pptx/Unit-02 Pointers.pptx
@@ -17,8 +17,8 @@
     <p:sldId id="281" r:id="rId8"/>
     <p:sldId id="282" r:id="rId9"/>
     <p:sldId id="284" r:id="rId10"/>
-    <p:sldId id="283" r:id="rId11"/>
-    <p:sldId id="285" r:id="rId12"/>
+    <p:sldId id="285" r:id="rId11"/>
+    <p:sldId id="283" r:id="rId12"/>
     <p:sldId id="286" r:id="rId13"/>
     <p:sldId id="287" r:id="rId14"/>
     <p:sldId id="288" r:id="rId15"/>
@@ -220,7 +220,7 @@
           <a:p>
             <a:fld id="{B2735D1C-2DAE-A844-AB28-6D356E73EE8D}" type="datetimeFigureOut">
               <a:rPr lang="en-US" smtClean="0"/>
-              <a:t>2/13/24</a:t>
+              <a:t>2/10/25</a:t>
             </a:fld>
             <a:endParaRPr lang="en-US"/>
           </a:p>
@@ -634,7 +634,7 @@
           <a:p>
             <a:fld id="{5FABD409-7894-914B-8B56-CBEFCA3FA783}" type="datetimeFigureOut">
               <a:rPr lang="en-US" smtClean="0"/>
-              <a:t>2/13/24</a:t>
+              <a:t>2/10/25</a:t>
             </a:fld>
             <a:endParaRPr lang="en-US"/>
           </a:p>
@@ -832,7 +832,7 @@
           <a:p>
             <a:fld id="{5FABD409-7894-914B-8B56-CBEFCA3FA783}" type="datetimeFigureOut">
               <a:rPr lang="en-US" smtClean="0"/>
-              <a:t>2/13/24</a:t>
+              <a:t>2/10/25</a:t>
             </a:fld>
             <a:endParaRPr lang="en-US"/>
           </a:p>
@@ -1040,7 +1040,7 @@
           <a:p>
             <a:fld id="{5FABD409-7894-914B-8B56-CBEFCA3FA783}" type="datetimeFigureOut">
               <a:rPr lang="en-US" smtClean="0"/>
-              <a:t>2/13/24</a:t>
+              <a:t>2/10/25</a:t>
             </a:fld>
             <a:endParaRPr lang="en-US"/>
           </a:p>
@@ -1238,7 +1238,7 @@
           <a:p>
             <a:fld id="{5FABD409-7894-914B-8B56-CBEFCA3FA783}" type="datetimeFigureOut">
               <a:rPr lang="en-US" smtClean="0"/>
-              <a:t>2/13/24</a:t>
+              <a:t>2/10/25</a:t>
             </a:fld>
             <a:endParaRPr lang="en-US"/>
           </a:p>
@@ -1513,7 +1513,7 @@
           <a:p>
             <a:fld id="{5FABD409-7894-914B-8B56-CBEFCA3FA783}" type="datetimeFigureOut">
               <a:rPr lang="en-US" smtClean="0"/>
-              <a:t>2/13/24</a:t>
+              <a:t>2/10/25</a:t>
             </a:fld>
             <a:endParaRPr lang="en-US"/>
           </a:p>
@@ -1778,7 +1778,7 @@
           <a:p>
             <a:fld id="{5FABD409-7894-914B-8B56-CBEFCA3FA783}" type="datetimeFigureOut">
               <a:rPr lang="en-US" smtClean="0"/>
-              <a:t>2/13/24</a:t>
+              <a:t>2/10/25</a:t>
             </a:fld>
             <a:endParaRPr lang="en-US"/>
           </a:p>
@@ -2190,7 +2190,7 @@
           <a:p>
             <a:fld id="{5FABD409-7894-914B-8B56-CBEFCA3FA783}" type="datetimeFigureOut">
               <a:rPr lang="en-US" smtClean="0"/>
-              <a:t>2/13/24</a:t>
+              <a:t>2/10/25</a:t>
             </a:fld>
             <a:endParaRPr lang="en-US"/>
           </a:p>
@@ -2331,7 +2331,7 @@
           <a:p>
             <a:fld id="{5FABD409-7894-914B-8B56-CBEFCA3FA783}" type="datetimeFigureOut">
               <a:rPr lang="en-US" smtClean="0"/>
-              <a:t>2/13/24</a:t>
+              <a:t>2/10/25</a:t>
             </a:fld>
             <a:endParaRPr lang="en-US"/>
           </a:p>
@@ -2444,7 +2444,7 @@
           <a:p>
             <a:fld id="{5FABD409-7894-914B-8B56-CBEFCA3FA783}" type="datetimeFigureOut">
               <a:rPr lang="en-US" smtClean="0"/>
-              <a:t>2/13/24</a:t>
+              <a:t>2/10/25</a:t>
             </a:fld>
             <a:endParaRPr lang="en-US"/>
           </a:p>
@@ -2755,7 +2755,7 @@
           <a:p>
             <a:fld id="{5FABD409-7894-914B-8B56-CBEFCA3FA783}" type="datetimeFigureOut">
               <a:rPr lang="en-US" smtClean="0"/>
-              <a:t>2/13/24</a:t>
+              <a:t>2/10/25</a:t>
             </a:fld>
             <a:endParaRPr lang="en-US"/>
           </a:p>
@@ -3043,7 +3043,7 @@
           <a:p>
             <a:fld id="{5FABD409-7894-914B-8B56-CBEFCA3FA783}" type="datetimeFigureOut">
               <a:rPr lang="en-US" smtClean="0"/>
-              <a:t>2/13/24</a:t>
+              <a:t>2/10/25</a:t>
             </a:fld>
             <a:endParaRPr lang="en-US"/>
           </a:p>
@@ -3284,7 +3284,7 @@
           <a:p>
             <a:fld id="{5FABD409-7894-914B-8B56-CBEFCA3FA783}" type="datetimeFigureOut">
               <a:rPr lang="en-US" smtClean="0"/>
-              <a:t>2/13/24</a:t>
+              <a:t>2/10/25</a:t>
             </a:fld>
             <a:endParaRPr lang="en-US"/>
           </a:p>
@@ -3804,6 +3804,120 @@
         <p:cNvPr id="1" name="">
           <a:extLst>
             <a:ext uri="{FF2B5EF4-FFF2-40B4-BE49-F238E27FC236}">
+              <a16:creationId xmlns:a16="http://schemas.microsoft.com/office/drawing/2014/main" id="{22DD4966-B93E-54CC-DDC3-4C216FE895A7}"/>
+            </a:ext>
+          </a:extLst>
+        </p:cNvPr>
+        <p:cNvGrpSpPr/>
+        <p:nvPr/>
+      </p:nvGrpSpPr>
+      <p:grpSpPr>
+        <a:xfrm>
+          <a:off x="0" y="0"/>
+          <a:ext cx="0" cy="0"/>
+          <a:chOff x="0" y="0"/>
+          <a:chExt cx="0" cy="0"/>
+        </a:xfrm>
+      </p:grpSpPr>
+      <p:sp>
+        <p:nvSpPr>
+          <p:cNvPr id="12" name="TextBox 11">
+            <a:extLst>
+              <a:ext uri="{FF2B5EF4-FFF2-40B4-BE49-F238E27FC236}">
+                <a16:creationId xmlns:a16="http://schemas.microsoft.com/office/drawing/2014/main" id="{C3FEA973-D2B0-781D-299A-4526CFF53632}"/>
+              </a:ext>
+            </a:extLst>
+          </p:cNvPr>
+          <p:cNvSpPr txBox="1"/>
+          <p:nvPr/>
+        </p:nvSpPr>
+        <p:spPr>
+          <a:xfrm>
+            <a:off x="4618566" y="1764888"/>
+            <a:ext cx="2954867" cy="646331"/>
+          </a:xfrm>
+          <a:prstGeom prst="rect">
+            <a:avLst/>
+          </a:prstGeom>
+          <a:noFill/>
+        </p:spPr>
+        <p:txBody>
+          <a:bodyPr wrap="square">
+            <a:spAutoFit/>
+          </a:bodyPr>
+          <a:lstStyle/>
+          <a:p>
+            <a:pPr algn="ctr"/>
+            <a:r>
+              <a:rPr lang="en-US" sz="1800" dirty="0">
+                <a:solidFill>
+                  <a:srgbClr val="FFC000"/>
+                </a:solidFill>
+              </a:rPr>
+              <a:t>What do you think will be the output of line 9?</a:t>
+            </a:r>
+            <a:endParaRPr lang="en-US" dirty="0"/>
+          </a:p>
+        </p:txBody>
+      </p:sp>
+      <p:pic>
+        <p:nvPicPr>
+          <p:cNvPr id="3" name="Picture 2">
+            <a:extLst>
+              <a:ext uri="{FF2B5EF4-FFF2-40B4-BE49-F238E27FC236}">
+                <a16:creationId xmlns:a16="http://schemas.microsoft.com/office/drawing/2014/main" id="{7372C551-48CF-2683-4FCB-DCE8C61C4DB2}"/>
+              </a:ext>
+            </a:extLst>
+          </p:cNvPr>
+          <p:cNvPicPr>
+            <a:picLocks noChangeAspect="1"/>
+          </p:cNvPicPr>
+          <p:nvPr/>
+        </p:nvPicPr>
+        <p:blipFill>
+          <a:blip r:embed="rId2"/>
+          <a:srcRect/>
+          <a:stretch/>
+        </p:blipFill>
+        <p:spPr>
+          <a:xfrm>
+            <a:off x="2492142" y="2406612"/>
+            <a:ext cx="7207716" cy="2955973"/>
+          </a:xfrm>
+          <a:prstGeom prst="rect">
+            <a:avLst/>
+          </a:prstGeom>
+        </p:spPr>
+      </p:pic>
+    </p:spTree>
+    <p:extLst>
+      <p:ext uri="{BB962C8B-B14F-4D97-AF65-F5344CB8AC3E}">
+        <p14:creationId xmlns:p14="http://schemas.microsoft.com/office/powerpoint/2010/main" val="2763851984"/>
+      </p:ext>
+    </p:extLst>
+  </p:cSld>
+  <p:clrMapOvr>
+    <a:masterClrMapping/>
+  </p:clrMapOvr>
+</p:sld>
+</file>
+
+<file path=ppt/slides/slide11.xml><?xml version="1.0" encoding="utf-8"?>
+<p:sld xmlns:a="http://schemas.openxmlformats.org/drawingml/2006/main" xmlns:r="http://schemas.openxmlformats.org/officeDocument/2006/relationships" xmlns:p="http://schemas.openxmlformats.org/presentationml/2006/main">
+  <p:cSld>
+    <p:bg>
+      <p:bgPr>
+        <a:solidFill>
+          <a:srgbClr val="343540"/>
+        </a:solidFill>
+        <a:effectLst/>
+      </p:bgPr>
+    </p:bg>
+    <p:spTree>
+      <p:nvGrpSpPr>
+        <p:cNvPr id="1" name="">
+          <a:extLst>
+            <a:ext uri="{FF2B5EF4-FFF2-40B4-BE49-F238E27FC236}">
               <a16:creationId xmlns:a16="http://schemas.microsoft.com/office/drawing/2014/main" id="{9CD8CB1B-9864-CFD1-635B-3B001981B607}"/>
             </a:ext>
           </a:extLst>
@@ -3983,120 +4097,6 @@
     <p:extLst>
       <p:ext uri="{BB962C8B-B14F-4D97-AF65-F5344CB8AC3E}">
         <p14:creationId xmlns:p14="http://schemas.microsoft.com/office/powerpoint/2010/main" val="3822571821"/>
-      </p:ext>
-    </p:extLst>
-  </p:cSld>
-  <p:clrMapOvr>
-    <a:masterClrMapping/>
-  </p:clrMapOvr>
-</p:sld>
-</file>
-
-<file path=ppt/slides/slide11.xml><?xml version="1.0" encoding="utf-8"?>
-<p:sld xmlns:a="http://schemas.openxmlformats.org/drawingml/2006/main" xmlns:r="http://schemas.openxmlformats.org/officeDocument/2006/relationships" xmlns:p="http://schemas.openxmlformats.org/presentationml/2006/main">
-  <p:cSld>
-    <p:bg>
-      <p:bgPr>
-        <a:solidFill>
-          <a:srgbClr val="343540"/>
-        </a:solidFill>
-        <a:effectLst/>
-      </p:bgPr>
-    </p:bg>
-    <p:spTree>
-      <p:nvGrpSpPr>
-        <p:cNvPr id="1" name="">
-          <a:extLst>
-            <a:ext uri="{FF2B5EF4-FFF2-40B4-BE49-F238E27FC236}">
-              <a16:creationId xmlns:a16="http://schemas.microsoft.com/office/drawing/2014/main" id="{22DD4966-B93E-54CC-DDC3-4C216FE895A7}"/>
-            </a:ext>
-          </a:extLst>
-        </p:cNvPr>
-        <p:cNvGrpSpPr/>
-        <p:nvPr/>
-      </p:nvGrpSpPr>
-      <p:grpSpPr>
-        <a:xfrm>
-          <a:off x="0" y="0"/>
-          <a:ext cx="0" cy="0"/>
-          <a:chOff x="0" y="0"/>
-          <a:chExt cx="0" cy="0"/>
-        </a:xfrm>
-      </p:grpSpPr>
-      <p:sp>
-        <p:nvSpPr>
-          <p:cNvPr id="12" name="TextBox 11">
-            <a:extLst>
-              <a:ext uri="{FF2B5EF4-FFF2-40B4-BE49-F238E27FC236}">
-                <a16:creationId xmlns:a16="http://schemas.microsoft.com/office/drawing/2014/main" id="{C3FEA973-D2B0-781D-299A-4526CFF53632}"/>
-              </a:ext>
-            </a:extLst>
-          </p:cNvPr>
-          <p:cNvSpPr txBox="1"/>
-          <p:nvPr/>
-        </p:nvSpPr>
-        <p:spPr>
-          <a:xfrm>
-            <a:off x="4618566" y="1764888"/>
-            <a:ext cx="2954867" cy="646331"/>
-          </a:xfrm>
-          <a:prstGeom prst="rect">
-            <a:avLst/>
-          </a:prstGeom>
-          <a:noFill/>
-        </p:spPr>
-        <p:txBody>
-          <a:bodyPr wrap="square">
-            <a:spAutoFit/>
-          </a:bodyPr>
-          <a:lstStyle/>
-          <a:p>
-            <a:pPr algn="ctr"/>
-            <a:r>
-              <a:rPr lang="en-US" sz="1800" dirty="0">
-                <a:solidFill>
-                  <a:srgbClr val="FFC000"/>
-                </a:solidFill>
-              </a:rPr>
-              <a:t>What do you think will be the output of line 9?</a:t>
-            </a:r>
-            <a:endParaRPr lang="en-US" dirty="0"/>
-          </a:p>
-        </p:txBody>
-      </p:sp>
-      <p:pic>
-        <p:nvPicPr>
-          <p:cNvPr id="3" name="Picture 2">
-            <a:extLst>
-              <a:ext uri="{FF2B5EF4-FFF2-40B4-BE49-F238E27FC236}">
-                <a16:creationId xmlns:a16="http://schemas.microsoft.com/office/drawing/2014/main" id="{7372C551-48CF-2683-4FCB-DCE8C61C4DB2}"/>
-              </a:ext>
-            </a:extLst>
-          </p:cNvPr>
-          <p:cNvPicPr>
-            <a:picLocks noChangeAspect="1"/>
-          </p:cNvPicPr>
-          <p:nvPr/>
-        </p:nvPicPr>
-        <p:blipFill>
-          <a:blip r:embed="rId2"/>
-          <a:srcRect/>
-          <a:stretch/>
-        </p:blipFill>
-        <p:spPr>
-          <a:xfrm>
-            <a:off x="2492142" y="2406612"/>
-            <a:ext cx="7207716" cy="2955973"/>
-          </a:xfrm>
-          <a:prstGeom prst="rect">
-            <a:avLst/>
-          </a:prstGeom>
-        </p:spPr>
-      </p:pic>
-    </p:spTree>
-    <p:extLst>
-      <p:ext uri="{BB962C8B-B14F-4D97-AF65-F5344CB8AC3E}">
-        <p14:creationId xmlns:p14="http://schemas.microsoft.com/office/powerpoint/2010/main" val="2763851984"/>
       </p:ext>
     </p:extLst>
   </p:cSld>
@@ -4180,7 +4180,7 @@
                   <a:srgbClr val="FFC000"/>
                 </a:solidFill>
               </a:rPr>
-              <a:t>last value of  will be</a:t>
+              <a:t>last value of ‘a’  will be</a:t>
             </a:r>
             <a:r>
               <a:rPr lang="en-US" sz="1800" dirty="0">

</xml_diff>